<commit_message>
Correct product format: cartridge → sachet (immersion in oil)
- Patent: rewrite all 16 claims for sachet construction (heat-resistant
  pouch, granulated MMT 0.3-0.5mm, immersion usage 15-30min)
- Manuscript: rewrite narrative from gravity-flow cartridge to consumer
  immersion sachet; fix Highlights ≤85 chars; fix PPTX font sizing for
  all paragraphs; unify cost basis at 300-500 JPY/kg
- Product design: sachet format CLAYPOT (80x100mm tea-bag, ¥498/3pcs),
  not cartridge
- Roadmap: update all references from cartridge to sachet format

Co-Authored-By: Tatsuki Onishi <bougtoir@gmail.com>
</commit_message>
<xml_diff>
--- a/montmorillonite_oil/figures_tables.pptx
+++ b/montmorillonite_oil/figures_tables.pptx
@@ -3116,7 +3116,7 @@
               <a:defRPr sz="1800" b="1"/>
             </a:pPr>
             <a:r>
-              <a:t>Table 1. Comparison of consumer oil pot filter technologies</a:t>
+              <a:t>Table 1. Comparison of consumer oil treatment technologies</a:t>
             </a:r>
           </a:p>
         </p:txBody>
@@ -3401,7 +3401,7 @@
                     <a:lstStyle/>
                     <a:p>
                       <a:r>
-                        <a:t>MMT cartridge (proposed)</a:t>
+                        <a:t>MMT sachet (proposed)</a:t>
                       </a:r>
                     </a:p>
                   </a:txBody>
@@ -3449,7 +3449,7 @@
                     <a:lstStyle/>
                     <a:p>
                       <a:r>
-                        <a:t>&gt;96%</a:t>
+                        <a:t>&gt;95%</a:t>
                       </a:r>
                     </a:p>
                   </a:txBody>
@@ -3504,7 +3504,7 @@
               <a:defRPr sz="1800" b="1"/>
             </a:pPr>
             <a:r>
-              <a:t>Table 2. Projected performance specifications for MMT oil restoration cartridge</a:t>
+              <a:t>Table 2. Projected performance for MMT oil restoration sachet</a:t>
             </a:r>
           </a:p>
         </p:txBody>
@@ -3564,19 +3564,19 @@
                     <a:lstStyle/>
                     <a:p>
                       <a:r>
-                        <a:t>Cartridge fill</a:t>
-                      </a:r>
-                    </a:p>
-                  </a:txBody>
-                  <a:tcPr/>
-                </a:tc>
-                <a:tc>
-                  <a:txBody>
-                    <a:bodyPr/>
-                    <a:lstStyle/>
-                    <a:p>
-                      <a:r>
-                        <a:t>30 g acid-activated MMT (0.8-1.5 mm)</a:t>
+                        <a:t>Sachet fill</a:t>
+                      </a:r>
+                    </a:p>
+                  </a:txBody>
+                  <a:tcPr/>
+                </a:tc>
+                <a:tc>
+                  <a:txBody>
+                    <a:bodyPr/>
+                    <a:lstStyle/>
+                    <a:p>
+                      <a:r>
+                        <a:t>25 g acid-activated MMT (0.3-0.5 mm)</a:t>
                       </a:r>
                     </a:p>
                   </a:txBody>
@@ -3590,7 +3590,7 @@
                     <a:lstStyle/>
                     <a:p>
                       <a:r>
-                        <a:t>Oil volume per pass</a:t>
+                        <a:t>Oil volume</a:t>
                       </a:r>
                     </a:p>
                   </a:txBody>
@@ -3616,19 +3616,19 @@
                     <a:lstStyle/>
                     <a:p>
                       <a:r>
-                        <a:t>Filtration temperature</a:t>
-                      </a:r>
-                    </a:p>
-                  </a:txBody>
-                  <a:tcPr/>
-                </a:tc>
-                <a:tc>
-                  <a:txBody>
-                    <a:bodyPr/>
-                    <a:lstStyle/>
-                    <a:p>
-                      <a:r>
-                        <a:t>50-100 C (recommended 80 C)</a:t>
+                        <a:t>Immersion temperature</a:t>
+                      </a:r>
+                    </a:p>
+                  </a:txBody>
+                  <a:tcPr/>
+                </a:tc>
+                <a:tc>
+                  <a:txBody>
+                    <a:bodyPr/>
+                    <a:lstStyle/>
+                    <a:p>
+                      <a:r>
+                        <a:t>50-80 C (recommended 80 C)</a:t>
                       </a:r>
                     </a:p>
                   </a:txBody>
@@ -3642,19 +3642,19 @@
                     <a:lstStyle/>
                     <a:p>
                       <a:r>
-                        <a:t>Flow time</a:t>
-                      </a:r>
-                    </a:p>
-                  </a:txBody>
-                  <a:tcPr/>
-                </a:tc>
-                <a:tc>
-                  <a:txBody>
-                    <a:bodyPr/>
-                    <a:lstStyle/>
-                    <a:p>
-                      <a:r>
-                        <a:t>2-5 min (gravity)</a:t>
+                        <a:t>Immersion time</a:t>
+                      </a:r>
+                    </a:p>
+                  </a:txBody>
+                  <a:tcPr/>
+                </a:tc>
+                <a:tc>
+                  <a:txBody>
+                    <a:bodyPr/>
+                    <a:lstStyle/>
+                    <a:p>
+                      <a:r>
+                        <a:t>15-30 min</a:t>
                       </a:r>
                     </a:p>
                   </a:txBody>
@@ -3680,7 +3680,7 @@
                     <a:lstStyle/>
                     <a:p>
                       <a:r>
-                        <a:t>30-50% per pass</a:t>
+                        <a:t>30-50% per immersion</a:t>
                       </a:r>
                     </a:p>
                   </a:txBody>
@@ -3706,7 +3706,7 @@
                     <a:lstStyle/>
                     <a:p>
                       <a:r>
-                        <a:t>20-40% per pass</a:t>
+                        <a:t>20-40% per immersion</a:t>
                       </a:r>
                     </a:p>
                   </a:txBody>
@@ -3732,7 +3732,7 @@
                     <a:lstStyle/>
                     <a:p>
                       <a:r>
-                        <a:t>40-70% per pass</a:t>
+                        <a:t>40-70% per immersion</a:t>
                       </a:r>
                     </a:p>
                   </a:txBody>
@@ -3758,7 +3758,7 @@
                     <a:lstStyle/>
                     <a:p>
                       <a:r>
-                        <a:t>&gt;96%</a:t>
+                        <a:t>&gt;95%</a:t>
                       </a:r>
                     </a:p>
                   </a:txBody>
@@ -3772,19 +3772,19 @@
                     <a:lstStyle/>
                     <a:p>
                       <a:r>
-                        <a:t>Cartridge lifetime</a:t>
-                      </a:r>
-                    </a:p>
-                  </a:txBody>
-                  <a:tcPr/>
-                </a:tc>
-                <a:tc>
-                  <a:txBody>
-                    <a:bodyPr/>
-                    <a:lstStyle/>
-                    <a:p>
-                      <a:r>
-                        <a:t>3-5 uses</a:t>
+                        <a:t>Sachet lifetime</a:t>
+                      </a:r>
+                    </a:p>
+                  </a:txBody>
+                  <a:tcPr/>
+                </a:tc>
+                <a:tc>
+                  <a:txBody>
+                    <a:bodyPr/>
+                    <a:lstStyle/>
+                    <a:p>
+                      <a:r>
+                        <a:t>2-3 uses</a:t>
                       </a:r>
                     </a:p>
                   </a:txBody>
@@ -3798,19 +3798,19 @@
                     <a:lstStyle/>
                     <a:p>
                       <a:r>
-                        <a:t>Cost per cartridge</a:t>
-                      </a:r>
-                    </a:p>
-                  </a:txBody>
-                  <a:tcPr/>
-                </a:tc>
-                <a:tc>
-                  <a:txBody>
-                    <a:bodyPr/>
-                    <a:lstStyle/>
-                    <a:p>
-                      <a:r>
-                        <a:t>200-400 JPY</a:t>
+                        <a:t>Cost per sachet</a:t>
+                      </a:r>
+                    </a:p>
+                  </a:txBody>
+                  <a:tcPr/>
+                </a:tc>
+                <a:tc>
+                  <a:txBody>
+                    <a:bodyPr/>
+                    <a:lstStyle/>
+                    <a:p>
+                      <a:r>
+                        <a:t>100-200 JPY</a:t>
                       </a:r>
                     </a:p>
                   </a:txBody>
@@ -3865,7 +3865,7 @@
               <a:defRPr sz="1800" b="1"/>
             </a:pPr>
             <a:r>
-              <a:t>Fig. 1. Industrial bleaching earth process vs. consumer cartridge format</a:t>
+              <a:t>Fig. 1. Industrial bleaching earth process vs. consumer sachet format</a:t>
             </a:r>
           </a:p>
         </p:txBody>
@@ -3899,46 +3899,78 @@
               <a:t>[Figure placeholder]</a:t>
             </a:r>
           </a:p>
-          <a:p/>
-          <a:p>
+          <a:p>
+            <a:pPr>
+              <a:defRPr sz="1400"/>
+            </a:pPr>
+          </a:p>
+          <a:p>
+            <a:pPr>
+              <a:defRPr sz="1400"/>
+            </a:pPr>
             <a:r>
               <a:t>Left panel: Industrial process</a:t>
             </a:r>
           </a:p>
           <a:p>
+            <a:pPr>
+              <a:defRPr sz="1400"/>
+            </a:pPr>
             <a:r>
               <a:t>- Powdered bleaching earth (&lt;0.1 mm) dispersed in oil</a:t>
             </a:r>
           </a:p>
           <a:p>
+            <a:pPr>
+              <a:defRPr sz="1400"/>
+            </a:pPr>
             <a:r>
               <a:t>- Mechanical agitation 20-60 min</a:t>
             </a:r>
           </a:p>
           <a:p>
+            <a:pPr>
+              <a:defRPr sz="1400"/>
+            </a:pPr>
             <a:r>
               <a:t>- Centrifugal separation</a:t>
             </a:r>
           </a:p>
-          <a:p/>
-          <a:p>
-            <a:r>
-              <a:t>Right panel: Consumer cartridge</a:t>
-            </a:r>
-          </a:p>
-          <a:p>
-            <a:r>
-              <a:t>- Granulated MMT (0.8-1.5 mm) in cartridge</a:t>
-            </a:r>
-          </a:p>
-          <a:p>
-            <a:r>
-              <a:t>- Gravity flow-through 2-5 min</a:t>
-            </a:r>
-          </a:p>
-          <a:p>
-            <a:r>
-              <a:t>- Drop-in oil pot compatible</a:t>
+          <a:p>
+            <a:pPr>
+              <a:defRPr sz="1400"/>
+            </a:pPr>
+          </a:p>
+          <a:p>
+            <a:pPr>
+              <a:defRPr sz="1400"/>
+            </a:pPr>
+            <a:r>
+              <a:t>Right panel: Consumer sachet</a:t>
+            </a:r>
+          </a:p>
+          <a:p>
+            <a:pPr>
+              <a:defRPr sz="1400"/>
+            </a:pPr>
+            <a:r>
+              <a:t>- Granulated MMT (0.3-0.5 mm) in tea-bag sachet</a:t>
+            </a:r>
+          </a:p>
+          <a:p>
+            <a:pPr>
+              <a:defRPr sz="1400"/>
+            </a:pPr>
+            <a:r>
+              <a:t>- Immersed in used oil 15-30 min</a:t>
+            </a:r>
+          </a:p>
+          <a:p>
+            <a:pPr>
+              <a:defRPr sz="1400"/>
+            </a:pPr>
+            <a:r>
+              <a:t>- Pull out and discard</a:t>
             </a:r>
           </a:p>
         </p:txBody>

</xml_diff>